<commit_message>
feat(pptx): read speaker notes and flag hidden slides
Each slide's notes part becomes a speaker-notes note at the end of its
section, from the notes body placeholder and plain text boxes. Slides with
show="0" are kept with hidden: true and one HIDDEN_CONTENT warning counts
them.
</commit_message>
<xml_diff>
--- a/corpus/pptx/reading-order.pptx
+++ b/corpus/pptx/reading-order.pptx
@@ -89,6 +89,75 @@
 </dgm:dataModel>
 </file>
 
+<file path=ppt/notesSlides/notesSlide1.xml><?xml version="1.0" encoding="utf-8"?>
+<p:notes xmlns:p="http://schemas.openxmlformats.org/presentationml/2006/main" xmlns:a="http://schemas.openxmlformats.org/drawingml/2006/main" xmlns:r="http://schemas.openxmlformats.org/officeDocument/2006/relationships">
+  <p:cSld>
+    <p:spTree>
+      <p:nvGrpSpPr>
+        <p:cNvPr id="1" name=""/>
+        <p:cNvGrpSpPr/>
+        <p:nvPr/>
+      </p:nvGrpSpPr>
+      <p:grpSpPr/>
+      <p:sp>
+        <p:nvSpPr>
+          <p:cNvPr id="15" name="Slide Image"/>
+          <p:cNvSpPr/>
+          <p:nvPr>
+            <p:ph type="sldImg"/>
+          </p:nvPr>
+        </p:nvSpPr>
+        <p:spPr/>
+      </p:sp>
+      <p:sp>
+        <p:nvSpPr>
+          <p:cNvPr id="16" name="Shape"/>
+          <p:cNvSpPr/>
+          <p:nvPr>
+            <p:ph type="body" idx="1"/>
+          </p:nvPr>
+        </p:nvSpPr>
+        <p:spPr/>
+        <p:txBody>
+          <a:bodyPr/>
+          <a:p>
+            <a:r>
+              <a:rPr lang="en-US"/>
+              <a:t>Start with the left column.</a:t>
+            </a:r>
+          </a:p>
+          <a:p>
+            <a:r>
+              <a:rPr lang="en-US"/>
+              <a:t>Then compare the right.</a:t>
+            </a:r>
+          </a:p>
+        </p:txBody>
+      </p:sp>
+      <p:sp>
+        <p:nvSpPr>
+          <p:cNvPr id="17" name="Shape"/>
+          <p:cNvSpPr/>
+          <p:nvPr>
+            <p:ph type="sldNum" idx="5"/>
+          </p:nvPr>
+        </p:nvSpPr>
+        <p:spPr/>
+        <p:txBody>
+          <a:bodyPr/>
+          <a:p>
+            <a:r>
+              <a:rPr lang="en-US"/>
+              <a:t>2</a:t>
+            </a:r>
+          </a:p>
+        </p:txBody>
+      </p:sp>
+    </p:spTree>
+  </p:cSld>
+</p:notes>
+</file>
+
 <file path=ppt/slideLayouts/slideLayout1.xml><?xml version="1.0" encoding="utf-8"?>
 <p:sldLayout xmlns:p="http://schemas.openxmlformats.org/presentationml/2006/main" xmlns:a="http://schemas.openxmlformats.org/drawingml/2006/main" xmlns:r="http://schemas.openxmlformats.org/officeDocument/2006/relationships">
   <p:cSld>
@@ -101,7 +170,7 @@
       <p:grpSpPr/>
       <p:sp>
         <p:nvSpPr>
-          <p:cNvPr id="22" name="Shape"/>
+          <p:cNvPr id="25" name="Shape"/>
           <p:cNvSpPr/>
           <p:nvPr>
             <p:ph type="ctrTitle"/>
@@ -125,7 +194,7 @@
       </p:sp>
       <p:sp>
         <p:nvSpPr>
-          <p:cNvPr id="23" name="Shape"/>
+          <p:cNvPr id="26" name="Shape"/>
           <p:cNvSpPr/>
           <p:nvPr>
             <p:ph type="subTitle" idx="3"/>
@@ -149,7 +218,7 @@
       </p:sp>
       <p:sp>
         <p:nvSpPr>
-          <p:cNvPr id="24" name="Shape"/>
+          <p:cNvPr id="27" name="Shape"/>
           <p:cNvSpPr/>
           <p:nvPr>
             <p:ph type="title"/>
@@ -173,7 +242,7 @@
       </p:sp>
       <p:sp>
         <p:nvSpPr>
-          <p:cNvPr id="25" name="Shape"/>
+          <p:cNvPr id="28" name="Shape"/>
           <p:cNvSpPr/>
           <p:nvPr>
             <p:ph idx="1"/>
@@ -197,7 +266,7 @@
       </p:sp>
       <p:sp>
         <p:nvSpPr>
-          <p:cNvPr id="26" name="Shape"/>
+          <p:cNvPr id="29" name="Shape"/>
           <p:cNvSpPr/>
           <p:nvPr>
             <p:ph idx="2"/>
@@ -236,7 +305,7 @@
       <p:grpSpPr/>
       <p:sp>
         <p:nvSpPr>
-          <p:cNvPr id="27" name="Shape"/>
+          <p:cNvPr id="30" name="Shape"/>
           <p:cNvSpPr/>
           <p:nvPr>
             <p:ph type="title"/>
@@ -267,7 +336,7 @@
 </file>
 
 <file path=ppt/slides/slide1.xml><?xml version="1.0" encoding="utf-8"?>
-<p:sld xmlns:p="http://schemas.openxmlformats.org/presentationml/2006/main" xmlns:a="http://schemas.openxmlformats.org/drawingml/2006/main" xmlns:r="http://schemas.openxmlformats.org/officeDocument/2006/relationships" xmlns:mc="http://schemas.openxmlformats.org/markup-compatibility/2006" xmlns:p14="http://schemas.microsoft.com/office/powerpoint/2010/main">
+<p:sld xmlns:p="http://schemas.openxmlformats.org/presentationml/2006/main" xmlns:a="http://schemas.openxmlformats.org/drawingml/2006/main" xmlns:r="http://schemas.openxmlformats.org/officeDocument/2006/relationships" xmlns:mc="http://schemas.openxmlformats.org/markup-compatibility/2006" xmlns:p14="http://schemas.microsoft.com/office/powerpoint/2010/main" show="0">
   <p:cSld>
     <p:spTree>
       <p:nvGrpSpPr>
@@ -762,7 +831,7 @@
       <p:grpSpPr/>
       <p:sp>
         <p:nvSpPr>
-          <p:cNvPr id="18" name="Shape"/>
+          <p:cNvPr id="21" name="Shape"/>
           <p:cNvSpPr/>
           <p:nvPr>
             <p:ph type="ftr" idx="11"/>
@@ -786,7 +855,7 @@
       </p:sp>
       <p:sp>
         <p:nvSpPr>
-          <p:cNvPr id="19" name="Shape"/>
+          <p:cNvPr id="22" name="Shape"/>
           <p:cNvSpPr/>
           <p:nvPr>
             <p:ph type="sldNum" idx="12"/>
@@ -810,7 +879,7 @@
       </p:sp>
       <p:sp>
         <p:nvSpPr>
-          <p:cNvPr id="20" name="Shape"/>
+          <p:cNvPr id="23" name="Shape"/>
           <p:cNvSpPr/>
           <p:nvPr>
             <p:ph type="dt" idx="10"/>
@@ -836,7 +905,7 @@
         <mc:Choice Requires="p14">
           <p:sp>
             <p:nvSpPr>
-              <p:cNvPr id="16" name="New"/>
+              <p:cNvPr id="19" name="New"/>
               <p:cNvSpPr/>
               <p:nvPr/>
             </p:nvSpPr>
@@ -860,7 +929,7 @@
         <mc:Fallback>
           <p:sp>
             <p:nvSpPr>
-              <p:cNvPr id="17" name="Old"/>
+              <p:cNvPr id="20" name="Old"/>
               <p:cNvSpPr/>
               <p:nvPr/>
             </p:nvSpPr>
@@ -884,7 +953,7 @@
       </mc:AlternateContent>
       <p:graphicFrame>
         <p:nvGraphicFramePr>
-          <p:cNvPr id="15" name="Diagram"/>
+          <p:cNvPr id="18" name="Diagram"/>
           <p:cNvGraphicFramePr/>
           <p:nvPr/>
         </p:nvGraphicFramePr>
@@ -900,7 +969,7 @@
       </p:graphicFrame>
       <p:sp>
         <p:nvSpPr>
-          <p:cNvPr id="21" name="Shape"/>
+          <p:cNvPr id="24" name="Shape"/>
           <p:cNvSpPr/>
           <p:nvPr>
             <p:ph type="title"/>

</xml_diff>

<commit_message>
feat(pptx): read speaker notes and flag hidden slides (#196)
Each slide's notes part becomes a speaker-notes note at the end of its
section, from the notes body placeholder and plain text boxes. Slides with
show="0" are kept with hidden: true and one HIDDEN_CONTENT warning counts
them.
</commit_message>
<xml_diff>
--- a/corpus/pptx/reading-order.pptx
+++ b/corpus/pptx/reading-order.pptx
@@ -89,6 +89,75 @@
 </dgm:dataModel>
 </file>
 
+<file path=ppt/notesSlides/notesSlide1.xml><?xml version="1.0" encoding="utf-8"?>
+<p:notes xmlns:p="http://schemas.openxmlformats.org/presentationml/2006/main" xmlns:a="http://schemas.openxmlformats.org/drawingml/2006/main" xmlns:r="http://schemas.openxmlformats.org/officeDocument/2006/relationships">
+  <p:cSld>
+    <p:spTree>
+      <p:nvGrpSpPr>
+        <p:cNvPr id="1" name=""/>
+        <p:cNvGrpSpPr/>
+        <p:nvPr/>
+      </p:nvGrpSpPr>
+      <p:grpSpPr/>
+      <p:sp>
+        <p:nvSpPr>
+          <p:cNvPr id="15" name="Slide Image"/>
+          <p:cNvSpPr/>
+          <p:nvPr>
+            <p:ph type="sldImg"/>
+          </p:nvPr>
+        </p:nvSpPr>
+        <p:spPr/>
+      </p:sp>
+      <p:sp>
+        <p:nvSpPr>
+          <p:cNvPr id="16" name="Shape"/>
+          <p:cNvSpPr/>
+          <p:nvPr>
+            <p:ph type="body" idx="1"/>
+          </p:nvPr>
+        </p:nvSpPr>
+        <p:spPr/>
+        <p:txBody>
+          <a:bodyPr/>
+          <a:p>
+            <a:r>
+              <a:rPr lang="en-US"/>
+              <a:t>Start with the left column.</a:t>
+            </a:r>
+          </a:p>
+          <a:p>
+            <a:r>
+              <a:rPr lang="en-US"/>
+              <a:t>Then compare the right.</a:t>
+            </a:r>
+          </a:p>
+        </p:txBody>
+      </p:sp>
+      <p:sp>
+        <p:nvSpPr>
+          <p:cNvPr id="17" name="Shape"/>
+          <p:cNvSpPr/>
+          <p:nvPr>
+            <p:ph type="sldNum" idx="5"/>
+          </p:nvPr>
+        </p:nvSpPr>
+        <p:spPr/>
+        <p:txBody>
+          <a:bodyPr/>
+          <a:p>
+            <a:r>
+              <a:rPr lang="en-US"/>
+              <a:t>2</a:t>
+            </a:r>
+          </a:p>
+        </p:txBody>
+      </p:sp>
+    </p:spTree>
+  </p:cSld>
+</p:notes>
+</file>
+
 <file path=ppt/slideLayouts/slideLayout1.xml><?xml version="1.0" encoding="utf-8"?>
 <p:sldLayout xmlns:p="http://schemas.openxmlformats.org/presentationml/2006/main" xmlns:a="http://schemas.openxmlformats.org/drawingml/2006/main" xmlns:r="http://schemas.openxmlformats.org/officeDocument/2006/relationships">
   <p:cSld>
@@ -101,7 +170,7 @@
       <p:grpSpPr/>
       <p:sp>
         <p:nvSpPr>
-          <p:cNvPr id="22" name="Shape"/>
+          <p:cNvPr id="25" name="Shape"/>
           <p:cNvSpPr/>
           <p:nvPr>
             <p:ph type="ctrTitle"/>
@@ -125,7 +194,7 @@
       </p:sp>
       <p:sp>
         <p:nvSpPr>
-          <p:cNvPr id="23" name="Shape"/>
+          <p:cNvPr id="26" name="Shape"/>
           <p:cNvSpPr/>
           <p:nvPr>
             <p:ph type="subTitle" idx="3"/>
@@ -149,7 +218,7 @@
       </p:sp>
       <p:sp>
         <p:nvSpPr>
-          <p:cNvPr id="24" name="Shape"/>
+          <p:cNvPr id="27" name="Shape"/>
           <p:cNvSpPr/>
           <p:nvPr>
             <p:ph type="title"/>
@@ -173,7 +242,7 @@
       </p:sp>
       <p:sp>
         <p:nvSpPr>
-          <p:cNvPr id="25" name="Shape"/>
+          <p:cNvPr id="28" name="Shape"/>
           <p:cNvSpPr/>
           <p:nvPr>
             <p:ph idx="1"/>
@@ -197,7 +266,7 @@
       </p:sp>
       <p:sp>
         <p:nvSpPr>
-          <p:cNvPr id="26" name="Shape"/>
+          <p:cNvPr id="29" name="Shape"/>
           <p:cNvSpPr/>
           <p:nvPr>
             <p:ph idx="2"/>
@@ -236,7 +305,7 @@
       <p:grpSpPr/>
       <p:sp>
         <p:nvSpPr>
-          <p:cNvPr id="27" name="Shape"/>
+          <p:cNvPr id="30" name="Shape"/>
           <p:cNvSpPr/>
           <p:nvPr>
             <p:ph type="title"/>
@@ -267,7 +336,7 @@
 </file>
 
 <file path=ppt/slides/slide1.xml><?xml version="1.0" encoding="utf-8"?>
-<p:sld xmlns:p="http://schemas.openxmlformats.org/presentationml/2006/main" xmlns:a="http://schemas.openxmlformats.org/drawingml/2006/main" xmlns:r="http://schemas.openxmlformats.org/officeDocument/2006/relationships" xmlns:mc="http://schemas.openxmlformats.org/markup-compatibility/2006" xmlns:p14="http://schemas.microsoft.com/office/powerpoint/2010/main">
+<p:sld xmlns:p="http://schemas.openxmlformats.org/presentationml/2006/main" xmlns:a="http://schemas.openxmlformats.org/drawingml/2006/main" xmlns:r="http://schemas.openxmlformats.org/officeDocument/2006/relationships" xmlns:mc="http://schemas.openxmlformats.org/markup-compatibility/2006" xmlns:p14="http://schemas.microsoft.com/office/powerpoint/2010/main" show="0">
   <p:cSld>
     <p:spTree>
       <p:nvGrpSpPr>
@@ -762,7 +831,7 @@
       <p:grpSpPr/>
       <p:sp>
         <p:nvSpPr>
-          <p:cNvPr id="18" name="Shape"/>
+          <p:cNvPr id="21" name="Shape"/>
           <p:cNvSpPr/>
           <p:nvPr>
             <p:ph type="ftr" idx="11"/>
@@ -786,7 +855,7 @@
       </p:sp>
       <p:sp>
         <p:nvSpPr>
-          <p:cNvPr id="19" name="Shape"/>
+          <p:cNvPr id="22" name="Shape"/>
           <p:cNvSpPr/>
           <p:nvPr>
             <p:ph type="sldNum" idx="12"/>
@@ -810,7 +879,7 @@
       </p:sp>
       <p:sp>
         <p:nvSpPr>
-          <p:cNvPr id="20" name="Shape"/>
+          <p:cNvPr id="23" name="Shape"/>
           <p:cNvSpPr/>
           <p:nvPr>
             <p:ph type="dt" idx="10"/>
@@ -836,7 +905,7 @@
         <mc:Choice Requires="p14">
           <p:sp>
             <p:nvSpPr>
-              <p:cNvPr id="16" name="New"/>
+              <p:cNvPr id="19" name="New"/>
               <p:cNvSpPr/>
               <p:nvPr/>
             </p:nvSpPr>
@@ -860,7 +929,7 @@
         <mc:Fallback>
           <p:sp>
             <p:nvSpPr>
-              <p:cNvPr id="17" name="Old"/>
+              <p:cNvPr id="20" name="Old"/>
               <p:cNvSpPr/>
               <p:nvPr/>
             </p:nvSpPr>
@@ -884,7 +953,7 @@
       </mc:AlternateContent>
       <p:graphicFrame>
         <p:nvGraphicFramePr>
-          <p:cNvPr id="15" name="Diagram"/>
+          <p:cNvPr id="18" name="Diagram"/>
           <p:cNvGraphicFramePr/>
           <p:nvPr/>
         </p:nvGraphicFramePr>
@@ -900,7 +969,7 @@
       </p:graphicFrame>
       <p:sp>
         <p:nvSpPr>
-          <p:cNvPr id="21" name="Shape"/>
+          <p:cNvPr id="24" name="Shape"/>
           <p:cNvSpPr/>
           <p:nvPr>
             <p:ph type="title"/>

</xml_diff>